<commit_message>
Add compact mechanism figure and update paper materials
</commit_message>
<xml_diff>
--- a/Presentation1.pptx
+++ b/Presentation1.pptx
@@ -5,12 +5,15 @@
     <p:sldMasterId id="2147483672" r:id="rId1"/>
   </p:sldMasterIdLst>
   <p:notesMasterIdLst>
-    <p:notesMasterId r:id="rId5"/>
+    <p:notesMasterId r:id="rId8"/>
   </p:notesMasterIdLst>
   <p:sldIdLst>
     <p:sldId id="256" r:id="rId2"/>
-    <p:sldId id="257" r:id="rId3"/>
-    <p:sldId id="258" r:id="rId4"/>
+    <p:sldId id="261" r:id="rId3"/>
+    <p:sldId id="260" r:id="rId4"/>
+    <p:sldId id="257" r:id="rId5"/>
+    <p:sldId id="258" r:id="rId6"/>
+    <p:sldId id="259" r:id="rId7"/>
   </p:sldIdLst>
   <p:sldSz cx="6858000" cy="9906000" type="A4"/>
   <p:notesSz cx="6858000" cy="9144000"/>
@@ -199,7 +202,7 @@
           <a:p>
             <a:fld id="{7AEE48FF-A905-6F4E-B47A-4BCCD2500F88}" type="datetimeFigureOut">
               <a:rPr lang="en-US" smtClean="0"/>
-              <a:t>9/8/26</a:t>
+              <a:t>9/24/26</a:t>
             </a:fld>
             <a:endParaRPr lang="en-US"/>
           </a:p>
@@ -551,6 +554,222 @@
 </p:notes>
 </file>
 
+<file path=ppt/notesSlides/notesSlide2.xml><?xml version="1.0" encoding="utf-8"?>
+<p:notes xmlns:a="http://schemas.openxmlformats.org/drawingml/2006/main" xmlns:r="http://schemas.openxmlformats.org/officeDocument/2006/relationships" xmlns:p="http://schemas.openxmlformats.org/presentationml/2006/main">
+  <p:cSld>
+    <p:spTree>
+      <p:nvGrpSpPr>
+        <p:cNvPr id="1" name="">
+          <a:extLst>
+            <a:ext uri="{FF2B5EF4-FFF2-40B4-BE49-F238E27FC236}">
+              <a16:creationId xmlns:a16="http://schemas.microsoft.com/office/drawing/2014/main" id="{5D5DC611-82C9-81BB-971A-093B454029A9}"/>
+            </a:ext>
+          </a:extLst>
+        </p:cNvPr>
+        <p:cNvGrpSpPr/>
+        <p:nvPr/>
+      </p:nvGrpSpPr>
+      <p:grpSpPr>
+        <a:xfrm>
+          <a:off x="0" y="0"/>
+          <a:ext cx="0" cy="0"/>
+          <a:chOff x="0" y="0"/>
+          <a:chExt cx="0" cy="0"/>
+        </a:xfrm>
+      </p:grpSpPr>
+      <p:sp>
+        <p:nvSpPr>
+          <p:cNvPr id="2" name="Slide Image Placeholder 1">
+            <a:extLst>
+              <a:ext uri="{FF2B5EF4-FFF2-40B4-BE49-F238E27FC236}">
+                <a16:creationId xmlns:a16="http://schemas.microsoft.com/office/drawing/2014/main" id="{D3A9EA9B-DA81-5940-55F0-C521AEA75A51}"/>
+              </a:ext>
+            </a:extLst>
+          </p:cNvPr>
+          <p:cNvSpPr>
+            <a:spLocks noGrp="1" noRot="1" noChangeAspect="1"/>
+          </p:cNvSpPr>
+          <p:nvPr>
+            <p:ph type="sldImg"/>
+          </p:nvPr>
+        </p:nvSpPr>
+        <p:spPr/>
+      </p:sp>
+      <p:sp>
+        <p:nvSpPr>
+          <p:cNvPr id="3" name="Notes Placeholder 2">
+            <a:extLst>
+              <a:ext uri="{FF2B5EF4-FFF2-40B4-BE49-F238E27FC236}">
+                <a16:creationId xmlns:a16="http://schemas.microsoft.com/office/drawing/2014/main" id="{BB230CC9-8DED-5D4C-C72B-80FFD5E2340C}"/>
+              </a:ext>
+            </a:extLst>
+          </p:cNvPr>
+          <p:cNvSpPr>
+            <a:spLocks noGrp="1"/>
+          </p:cNvSpPr>
+          <p:nvPr>
+            <p:ph type="body" idx="1"/>
+          </p:nvPr>
+        </p:nvSpPr>
+        <p:spPr/>
+        <p:txBody>
+          <a:bodyPr/>
+          <a:lstStyle/>
+          <a:p>
+            <a:endParaRPr lang="en-US" dirty="0"/>
+          </a:p>
+        </p:txBody>
+      </p:sp>
+      <p:sp>
+        <p:nvSpPr>
+          <p:cNvPr id="4" name="Slide Number Placeholder 3">
+            <a:extLst>
+              <a:ext uri="{FF2B5EF4-FFF2-40B4-BE49-F238E27FC236}">
+                <a16:creationId xmlns:a16="http://schemas.microsoft.com/office/drawing/2014/main" id="{E866ED95-D6C7-B508-0FD3-5C78499573CC}"/>
+              </a:ext>
+            </a:extLst>
+          </p:cNvPr>
+          <p:cNvSpPr>
+            <a:spLocks noGrp="1"/>
+          </p:cNvSpPr>
+          <p:nvPr>
+            <p:ph type="sldNum" sz="quarter" idx="5"/>
+          </p:nvPr>
+        </p:nvSpPr>
+        <p:spPr/>
+        <p:txBody>
+          <a:bodyPr/>
+          <a:lstStyle/>
+          <a:p>
+            <a:fld id="{2220719A-A226-1E4D-8CA0-3A697BFCDBEA}" type="slidenum">
+              <a:rPr lang="en-US" smtClean="0"/>
+              <a:t>2</a:t>
+            </a:fld>
+            <a:endParaRPr lang="en-US"/>
+          </a:p>
+        </p:txBody>
+      </p:sp>
+    </p:spTree>
+    <p:extLst>
+      <p:ext uri="{BB962C8B-B14F-4D97-AF65-F5344CB8AC3E}">
+        <p14:creationId xmlns:p14="http://schemas.microsoft.com/office/powerpoint/2010/main" val="293230837"/>
+      </p:ext>
+    </p:extLst>
+  </p:cSld>
+  <p:clrMapOvr>
+    <a:masterClrMapping/>
+  </p:clrMapOvr>
+</p:notes>
+</file>
+
+<file path=ppt/notesSlides/notesSlide3.xml><?xml version="1.0" encoding="utf-8"?>
+<p:notes xmlns:a="http://schemas.openxmlformats.org/drawingml/2006/main" xmlns:r="http://schemas.openxmlformats.org/officeDocument/2006/relationships" xmlns:p="http://schemas.openxmlformats.org/presentationml/2006/main">
+  <p:cSld>
+    <p:spTree>
+      <p:nvGrpSpPr>
+        <p:cNvPr id="1" name="">
+          <a:extLst>
+            <a:ext uri="{FF2B5EF4-FFF2-40B4-BE49-F238E27FC236}">
+              <a16:creationId xmlns:a16="http://schemas.microsoft.com/office/drawing/2014/main" id="{14EDD430-A3DA-EE2B-7BA4-7C8BEDD2BC59}"/>
+            </a:ext>
+          </a:extLst>
+        </p:cNvPr>
+        <p:cNvGrpSpPr/>
+        <p:nvPr/>
+      </p:nvGrpSpPr>
+      <p:grpSpPr>
+        <a:xfrm>
+          <a:off x="0" y="0"/>
+          <a:ext cx="0" cy="0"/>
+          <a:chOff x="0" y="0"/>
+          <a:chExt cx="0" cy="0"/>
+        </a:xfrm>
+      </p:grpSpPr>
+      <p:sp>
+        <p:nvSpPr>
+          <p:cNvPr id="2" name="Slide Image Placeholder 1">
+            <a:extLst>
+              <a:ext uri="{FF2B5EF4-FFF2-40B4-BE49-F238E27FC236}">
+                <a16:creationId xmlns:a16="http://schemas.microsoft.com/office/drawing/2014/main" id="{0B494DFF-D550-0BA6-2D13-70F69A97609D}"/>
+              </a:ext>
+            </a:extLst>
+          </p:cNvPr>
+          <p:cNvSpPr>
+            <a:spLocks noGrp="1" noRot="1" noChangeAspect="1"/>
+          </p:cNvSpPr>
+          <p:nvPr>
+            <p:ph type="sldImg"/>
+          </p:nvPr>
+        </p:nvSpPr>
+        <p:spPr/>
+      </p:sp>
+      <p:sp>
+        <p:nvSpPr>
+          <p:cNvPr id="3" name="Notes Placeholder 2">
+            <a:extLst>
+              <a:ext uri="{FF2B5EF4-FFF2-40B4-BE49-F238E27FC236}">
+                <a16:creationId xmlns:a16="http://schemas.microsoft.com/office/drawing/2014/main" id="{DFA913FD-D8BF-92D9-4F53-778212A80E39}"/>
+              </a:ext>
+            </a:extLst>
+          </p:cNvPr>
+          <p:cNvSpPr>
+            <a:spLocks noGrp="1"/>
+          </p:cNvSpPr>
+          <p:nvPr>
+            <p:ph type="body" idx="1"/>
+          </p:nvPr>
+        </p:nvSpPr>
+        <p:spPr/>
+        <p:txBody>
+          <a:bodyPr/>
+          <a:lstStyle/>
+          <a:p>
+            <a:endParaRPr lang="en-US" dirty="0"/>
+          </a:p>
+        </p:txBody>
+      </p:sp>
+      <p:sp>
+        <p:nvSpPr>
+          <p:cNvPr id="4" name="Slide Number Placeholder 3">
+            <a:extLst>
+              <a:ext uri="{FF2B5EF4-FFF2-40B4-BE49-F238E27FC236}">
+                <a16:creationId xmlns:a16="http://schemas.microsoft.com/office/drawing/2014/main" id="{9DC2A423-0FFB-4589-9334-445BC23CE95F}"/>
+              </a:ext>
+            </a:extLst>
+          </p:cNvPr>
+          <p:cNvSpPr>
+            <a:spLocks noGrp="1"/>
+          </p:cNvSpPr>
+          <p:nvPr>
+            <p:ph type="sldNum" sz="quarter" idx="5"/>
+          </p:nvPr>
+        </p:nvSpPr>
+        <p:spPr/>
+        <p:txBody>
+          <a:bodyPr/>
+          <a:lstStyle/>
+          <a:p>
+            <a:fld id="{2220719A-A226-1E4D-8CA0-3A697BFCDBEA}" type="slidenum">
+              <a:rPr lang="en-US" smtClean="0"/>
+              <a:t>3</a:t>
+            </a:fld>
+            <a:endParaRPr lang="en-US"/>
+          </a:p>
+        </p:txBody>
+      </p:sp>
+    </p:spTree>
+    <p:extLst>
+      <p:ext uri="{BB962C8B-B14F-4D97-AF65-F5344CB8AC3E}">
+        <p14:creationId xmlns:p14="http://schemas.microsoft.com/office/powerpoint/2010/main" val="343057118"/>
+      </p:ext>
+    </p:extLst>
+  </p:cSld>
+  <p:clrMapOvr>
+    <a:masterClrMapping/>
+  </p:clrMapOvr>
+</p:notes>
+</file>
+
 <file path=ppt/slideLayouts/slideLayout1.xml><?xml version="1.0" encoding="utf-8"?>
 <p:sldLayout xmlns:a="http://schemas.openxmlformats.org/drawingml/2006/main" xmlns:r="http://schemas.openxmlformats.org/officeDocument/2006/relationships" xmlns:p="http://schemas.openxmlformats.org/presentationml/2006/main" type="title" preserve="1">
   <p:cSld name="Title Slide">
@@ -682,7 +901,7 @@
           <a:p>
             <a:fld id="{7B9D1F42-D334-4E49-BFF9-14F679444531}" type="datetimeFigureOut">
               <a:rPr lang="en-US" smtClean="0"/>
-              <a:t>9/8/26</a:t>
+              <a:t>9/24/26</a:t>
             </a:fld>
             <a:endParaRPr lang="en-US"/>
           </a:p>
@@ -852,7 +1071,7 @@
           <a:p>
             <a:fld id="{7B9D1F42-D334-4E49-BFF9-14F679444531}" type="datetimeFigureOut">
               <a:rPr lang="en-US" smtClean="0"/>
-              <a:t>9/8/26</a:t>
+              <a:t>9/24/26</a:t>
             </a:fld>
             <a:endParaRPr lang="en-US"/>
           </a:p>
@@ -1032,7 +1251,7 @@
           <a:p>
             <a:fld id="{7B9D1F42-D334-4E49-BFF9-14F679444531}" type="datetimeFigureOut">
               <a:rPr lang="en-US" smtClean="0"/>
-              <a:t>9/8/26</a:t>
+              <a:t>9/24/26</a:t>
             </a:fld>
             <a:endParaRPr lang="en-US"/>
           </a:p>
@@ -1202,7 +1421,7 @@
           <a:p>
             <a:fld id="{7B9D1F42-D334-4E49-BFF9-14F679444531}" type="datetimeFigureOut">
               <a:rPr lang="en-US" smtClean="0"/>
-              <a:t>9/8/26</a:t>
+              <a:t>9/24/26</a:t>
             </a:fld>
             <a:endParaRPr lang="en-US"/>
           </a:p>
@@ -1448,7 +1667,7 @@
           <a:p>
             <a:fld id="{7B9D1F42-D334-4E49-BFF9-14F679444531}" type="datetimeFigureOut">
               <a:rPr lang="en-US" smtClean="0"/>
-              <a:t>9/8/26</a:t>
+              <a:t>9/24/26</a:t>
             </a:fld>
             <a:endParaRPr lang="en-US"/>
           </a:p>
@@ -1680,7 +1899,7 @@
           <a:p>
             <a:fld id="{7B9D1F42-D334-4E49-BFF9-14F679444531}" type="datetimeFigureOut">
               <a:rPr lang="en-US" smtClean="0"/>
-              <a:t>9/8/26</a:t>
+              <a:t>9/24/26</a:t>
             </a:fld>
             <a:endParaRPr lang="en-US"/>
           </a:p>
@@ -2047,7 +2266,7 @@
           <a:p>
             <a:fld id="{7B9D1F42-D334-4E49-BFF9-14F679444531}" type="datetimeFigureOut">
               <a:rPr lang="en-US" smtClean="0"/>
-              <a:t>9/8/26</a:t>
+              <a:t>9/24/26</a:t>
             </a:fld>
             <a:endParaRPr lang="en-US"/>
           </a:p>
@@ -2165,7 +2384,7 @@
           <a:p>
             <a:fld id="{7B9D1F42-D334-4E49-BFF9-14F679444531}" type="datetimeFigureOut">
               <a:rPr lang="en-US" smtClean="0"/>
-              <a:t>9/8/26</a:t>
+              <a:t>9/24/26</a:t>
             </a:fld>
             <a:endParaRPr lang="en-US"/>
           </a:p>
@@ -2260,7 +2479,7 @@
           <a:p>
             <a:fld id="{7B9D1F42-D334-4E49-BFF9-14F679444531}" type="datetimeFigureOut">
               <a:rPr lang="en-US" smtClean="0"/>
-              <a:t>9/8/26</a:t>
+              <a:t>9/24/26</a:t>
             </a:fld>
             <a:endParaRPr lang="en-US"/>
           </a:p>
@@ -2537,7 +2756,7 @@
           <a:p>
             <a:fld id="{7B9D1F42-D334-4E49-BFF9-14F679444531}" type="datetimeFigureOut">
               <a:rPr lang="en-US" smtClean="0"/>
-              <a:t>9/8/26</a:t>
+              <a:t>9/24/26</a:t>
             </a:fld>
             <a:endParaRPr lang="en-US"/>
           </a:p>
@@ -2794,7 +3013,7 @@
           <a:p>
             <a:fld id="{7B9D1F42-D334-4E49-BFF9-14F679444531}" type="datetimeFigureOut">
               <a:rPr lang="en-US" smtClean="0"/>
-              <a:t>9/8/26</a:t>
+              <a:t>9/24/26</a:t>
             </a:fld>
             <a:endParaRPr lang="en-US"/>
           </a:p>
@@ -3007,7 +3226,7 @@
           <a:p>
             <a:fld id="{7B9D1F42-D334-4E49-BFF9-14F679444531}" type="datetimeFigureOut">
               <a:rPr lang="en-US" smtClean="0"/>
-              <a:t>9/8/26</a:t>
+              <a:t>9/24/26</a:t>
             </a:fld>
             <a:endParaRPr lang="en-US"/>
           </a:p>
@@ -3414,10 +3633,10 @@
       </p:grpSpPr>
       <p:pic>
         <p:nvPicPr>
-          <p:cNvPr id="7" name="Picture 6">
+          <p:cNvPr id="9" name="Picture 8">
             <a:extLst>
               <a:ext uri="{FF2B5EF4-FFF2-40B4-BE49-F238E27FC236}">
-                <a16:creationId xmlns:a16="http://schemas.microsoft.com/office/drawing/2014/main" id="{FC64E522-E70F-7026-E882-4D0DA7DDFD81}"/>
+                <a16:creationId xmlns:a16="http://schemas.microsoft.com/office/drawing/2014/main" id="{6434B70F-2438-7001-FB1A-29D86D186F4E}"/>
               </a:ext>
             </a:extLst>
           </p:cNvPr>
@@ -3434,8 +3653,8 @@
         </p:blipFill>
         <p:spPr>
           <a:xfrm>
-            <a:off x="0" y="494066"/>
-            <a:ext cx="6858000" cy="8917867"/>
+            <a:off x="0" y="1326518"/>
+            <a:ext cx="6858000" cy="7252964"/>
           </a:xfrm>
           <a:prstGeom prst="rect">
             <a:avLst/>
@@ -3444,10 +3663,10 @@
       </p:pic>
       <p:pic>
         <p:nvPicPr>
-          <p:cNvPr id="5" name="Picture 4">
+          <p:cNvPr id="2" name="Picture 1">
             <a:extLst>
               <a:ext uri="{FF2B5EF4-FFF2-40B4-BE49-F238E27FC236}">
-                <a16:creationId xmlns:a16="http://schemas.microsoft.com/office/drawing/2014/main" id="{0C5A7055-47F8-706F-68CB-6E6F8CA6A2FB}"/>
+                <a16:creationId xmlns:a16="http://schemas.microsoft.com/office/drawing/2014/main" id="{CEEFE8BA-3A83-F4CA-2F93-0B6C69502195}"/>
               </a:ext>
             </a:extLst>
           </p:cNvPr>
@@ -3458,13 +3677,13 @@
         </p:nvPicPr>
         <p:blipFill>
           <a:blip r:embed="rId4"/>
-          <a:srcRect l="2261" r="26265"/>
+          <a:srcRect t="2834"/>
           <a:stretch/>
         </p:blipFill>
         <p:spPr>
           <a:xfrm>
-            <a:off x="3517553" y="5596752"/>
-            <a:ext cx="2734963" cy="1794799"/>
+            <a:off x="1626260" y="2816352"/>
+            <a:ext cx="1707022" cy="512064"/>
           </a:xfrm>
           <a:prstGeom prst="rect">
             <a:avLst/>
@@ -3473,10 +3692,10 @@
       </p:pic>
       <p:pic>
         <p:nvPicPr>
-          <p:cNvPr id="8" name="Picture 7">
+          <p:cNvPr id="3" name="Picture 2">
             <a:extLst>
               <a:ext uri="{FF2B5EF4-FFF2-40B4-BE49-F238E27FC236}">
-                <a16:creationId xmlns:a16="http://schemas.microsoft.com/office/drawing/2014/main" id="{2E55E686-FCDA-5894-A4A8-2E0A39C21073}"/>
+                <a16:creationId xmlns:a16="http://schemas.microsoft.com/office/drawing/2014/main" id="{753A8E11-B550-DEBA-A429-36D486E9D174}"/>
               </a:ext>
             </a:extLst>
           </p:cNvPr>
@@ -3487,13 +3706,13 @@
         </p:nvPicPr>
         <p:blipFill>
           <a:blip r:embed="rId5"/>
-          <a:srcRect l="1776" t="10444" r="26409"/>
+          <a:srcRect l="-157" t="123"/>
           <a:stretch/>
         </p:blipFill>
         <p:spPr>
           <a:xfrm>
-            <a:off x="3490053" y="7218552"/>
-            <a:ext cx="2770702" cy="1620647"/>
+            <a:off x="1988780" y="3328417"/>
+            <a:ext cx="1339634" cy="621170"/>
           </a:xfrm>
           <a:prstGeom prst="rect">
             <a:avLst/>
@@ -3514,6 +3733,823 @@
 </file>
 
 <file path=ppt/slides/slide2.xml><?xml version="1.0" encoding="utf-8"?>
+<p:sld xmlns:a="http://schemas.openxmlformats.org/drawingml/2006/main" xmlns:r="http://schemas.openxmlformats.org/officeDocument/2006/relationships" xmlns:p="http://schemas.openxmlformats.org/presentationml/2006/main">
+  <p:cSld>
+    <p:spTree>
+      <p:nvGrpSpPr>
+        <p:cNvPr id="1" name="">
+          <a:extLst>
+            <a:ext uri="{FF2B5EF4-FFF2-40B4-BE49-F238E27FC236}">
+              <a16:creationId xmlns:a16="http://schemas.microsoft.com/office/drawing/2014/main" id="{4BB4D5D5-C2AD-183A-D768-6C9FC58E2230}"/>
+            </a:ext>
+          </a:extLst>
+        </p:cNvPr>
+        <p:cNvGrpSpPr/>
+        <p:nvPr/>
+      </p:nvGrpSpPr>
+      <p:grpSpPr>
+        <a:xfrm>
+          <a:off x="0" y="0"/>
+          <a:ext cx="0" cy="0"/>
+          <a:chOff x="0" y="0"/>
+          <a:chExt cx="0" cy="0"/>
+        </a:xfrm>
+      </p:grpSpPr>
+      <p:sp>
+        <p:nvSpPr>
+          <p:cNvPr id="12" name="Rectangle 11">
+            <a:extLst>
+              <a:ext uri="{FF2B5EF4-FFF2-40B4-BE49-F238E27FC236}">
+                <a16:creationId xmlns:a16="http://schemas.microsoft.com/office/drawing/2014/main" id="{8A1C1A00-6142-7D1B-C9E4-EDFF6BB702A9}"/>
+              </a:ext>
+            </a:extLst>
+          </p:cNvPr>
+          <p:cNvSpPr/>
+          <p:nvPr/>
+        </p:nvSpPr>
+        <p:spPr>
+          <a:xfrm>
+            <a:off x="1717693" y="4042509"/>
+            <a:ext cx="1598400" cy="45719"/>
+          </a:xfrm>
+          <a:prstGeom prst="rect">
+            <a:avLst/>
+          </a:prstGeom>
+          <a:solidFill>
+            <a:srgbClr val="5C9CD7"/>
+          </a:solidFill>
+          <a:ln>
+            <a:noFill/>
+          </a:ln>
+        </p:spPr>
+        <p:style>
+          <a:lnRef idx="2">
+            <a:schemeClr val="accent1">
+              <a:shade val="15000"/>
+            </a:schemeClr>
+          </a:lnRef>
+          <a:fillRef idx="1">
+            <a:schemeClr val="accent1"/>
+          </a:fillRef>
+          <a:effectRef idx="0">
+            <a:schemeClr val="accent1"/>
+          </a:effectRef>
+          <a:fontRef idx="minor">
+            <a:schemeClr val="lt1"/>
+          </a:fontRef>
+        </p:style>
+        <p:txBody>
+          <a:bodyPr rtlCol="0" anchor="ctr"/>
+          <a:lstStyle/>
+          <a:p>
+            <a:pPr algn="ctr"/>
+            <a:endParaRPr lang="en-US"/>
+          </a:p>
+        </p:txBody>
+      </p:sp>
+      <p:sp>
+        <p:nvSpPr>
+          <p:cNvPr id="11" name="Rectangle 10">
+            <a:extLst>
+              <a:ext uri="{FF2B5EF4-FFF2-40B4-BE49-F238E27FC236}">
+                <a16:creationId xmlns:a16="http://schemas.microsoft.com/office/drawing/2014/main" id="{AEF4DA38-1C37-A04E-47E6-2DC74C190646}"/>
+              </a:ext>
+            </a:extLst>
+          </p:cNvPr>
+          <p:cNvSpPr/>
+          <p:nvPr/>
+        </p:nvSpPr>
+        <p:spPr>
+          <a:xfrm>
+            <a:off x="1715180" y="2928548"/>
+            <a:ext cx="1598400" cy="45719"/>
+          </a:xfrm>
+          <a:prstGeom prst="rect">
+            <a:avLst/>
+          </a:prstGeom>
+          <a:solidFill>
+            <a:srgbClr val="5C9CD7"/>
+          </a:solidFill>
+          <a:ln>
+            <a:noFill/>
+          </a:ln>
+        </p:spPr>
+        <p:style>
+          <a:lnRef idx="2">
+            <a:schemeClr val="accent1">
+              <a:shade val="15000"/>
+            </a:schemeClr>
+          </a:lnRef>
+          <a:fillRef idx="1">
+            <a:schemeClr val="accent1"/>
+          </a:fillRef>
+          <a:effectRef idx="0">
+            <a:schemeClr val="accent1"/>
+          </a:effectRef>
+          <a:fontRef idx="minor">
+            <a:schemeClr val="lt1"/>
+          </a:fontRef>
+        </p:style>
+        <p:txBody>
+          <a:bodyPr rtlCol="0" anchor="ctr"/>
+          <a:lstStyle/>
+          <a:p>
+            <a:pPr algn="ctr"/>
+            <a:endParaRPr lang="en-US"/>
+          </a:p>
+        </p:txBody>
+      </p:sp>
+      <p:pic>
+        <p:nvPicPr>
+          <p:cNvPr id="9" name="Picture 8">
+            <a:extLst>
+              <a:ext uri="{FF2B5EF4-FFF2-40B4-BE49-F238E27FC236}">
+                <a16:creationId xmlns:a16="http://schemas.microsoft.com/office/drawing/2014/main" id="{6C5B6541-8BE1-B75C-BFF6-DE5390FF186E}"/>
+              </a:ext>
+            </a:extLst>
+          </p:cNvPr>
+          <p:cNvPicPr>
+            <a:picLocks noChangeAspect="1"/>
+          </p:cNvPicPr>
+          <p:nvPr/>
+        </p:nvPicPr>
+        <p:blipFill>
+          <a:blip r:embed="rId3"/>
+          <a:srcRect l="50000"/>
+          <a:stretch/>
+        </p:blipFill>
+        <p:spPr>
+          <a:xfrm>
+            <a:off x="3429000" y="1326518"/>
+            <a:ext cx="3429000" cy="7252964"/>
+          </a:xfrm>
+          <a:prstGeom prst="rect">
+            <a:avLst/>
+          </a:prstGeom>
+        </p:spPr>
+      </p:pic>
+      <p:pic>
+        <p:nvPicPr>
+          <p:cNvPr id="3" name="Picture 2">
+            <a:extLst>
+              <a:ext uri="{FF2B5EF4-FFF2-40B4-BE49-F238E27FC236}">
+                <a16:creationId xmlns:a16="http://schemas.microsoft.com/office/drawing/2014/main" id="{414B2C5A-F798-F4D4-BF6E-5557A03CF8B9}"/>
+              </a:ext>
+            </a:extLst>
+          </p:cNvPr>
+          <p:cNvPicPr>
+            <a:picLocks noChangeAspect="1"/>
+          </p:cNvPicPr>
+          <p:nvPr/>
+        </p:nvPicPr>
+        <p:blipFill>
+          <a:blip r:embed="rId4"/>
+          <a:srcRect l="-157" t="123"/>
+          <a:stretch/>
+        </p:blipFill>
+        <p:spPr>
+          <a:xfrm>
+            <a:off x="1719918" y="4604278"/>
+            <a:ext cx="1598689" cy="465492"/>
+          </a:xfrm>
+          <a:prstGeom prst="rect">
+            <a:avLst/>
+          </a:prstGeom>
+        </p:spPr>
+      </p:pic>
+      <p:pic>
+        <p:nvPicPr>
+          <p:cNvPr id="5" name="Picture 4">
+            <a:extLst>
+              <a:ext uri="{FF2B5EF4-FFF2-40B4-BE49-F238E27FC236}">
+                <a16:creationId xmlns:a16="http://schemas.microsoft.com/office/drawing/2014/main" id="{826E8377-11AF-BDAC-4AAD-80A5C11FA198}"/>
+              </a:ext>
+            </a:extLst>
+          </p:cNvPr>
+          <p:cNvPicPr>
+            <a:picLocks noChangeAspect="1"/>
+          </p:cNvPicPr>
+          <p:nvPr/>
+        </p:nvPicPr>
+        <p:blipFill>
+          <a:blip r:embed="rId3"/>
+          <a:srcRect t="62162"/>
+          <a:stretch/>
+        </p:blipFill>
+        <p:spPr>
+          <a:xfrm>
+            <a:off x="0" y="5835112"/>
+            <a:ext cx="6858000" cy="2744370"/>
+          </a:xfrm>
+          <a:prstGeom prst="rect">
+            <a:avLst/>
+          </a:prstGeom>
+        </p:spPr>
+      </p:pic>
+      <p:sp>
+        <p:nvSpPr>
+          <p:cNvPr id="6" name="TextBox 5">
+            <a:extLst>
+              <a:ext uri="{FF2B5EF4-FFF2-40B4-BE49-F238E27FC236}">
+                <a16:creationId xmlns:a16="http://schemas.microsoft.com/office/drawing/2014/main" id="{502ACFCF-377A-06DC-BEDA-62AE0E2D8ABD}"/>
+              </a:ext>
+            </a:extLst>
+          </p:cNvPr>
+          <p:cNvSpPr txBox="1"/>
+          <p:nvPr/>
+        </p:nvSpPr>
+        <p:spPr>
+          <a:xfrm>
+            <a:off x="1049761" y="5040469"/>
+            <a:ext cx="2612079" cy="184666"/>
+          </a:xfrm>
+          <a:prstGeom prst="rect">
+            <a:avLst/>
+          </a:prstGeom>
+          <a:noFill/>
+        </p:spPr>
+        <p:txBody>
+          <a:bodyPr wrap="square" rtlCol="0">
+            <a:spAutoFit/>
+          </a:bodyPr>
+          <a:lstStyle/>
+          <a:p>
+            <a:pPr algn="ctr"/>
+            <a:r>
+              <a:rPr lang="en-US" sz="600" i="1" dirty="0">
+                <a:latin typeface="Times New Roman" panose="02020603050405020304" pitchFamily="18" charset="0"/>
+                <a:cs typeface="Times New Roman" panose="02020603050405020304" pitchFamily="18" charset="0"/>
+              </a:rPr>
+              <a:t>Note</a:t>
+            </a:r>
+            <a:r>
+              <a:rPr lang="en-US" sz="600" dirty="0">
+                <a:latin typeface="Times New Roman" panose="02020603050405020304" pitchFamily="18" charset="0"/>
+                <a:cs typeface="Times New Roman" panose="02020603050405020304" pitchFamily="18" charset="0"/>
+              </a:rPr>
+              <a:t>: </a:t>
+            </a:r>
+            <a:r>
+              <a:rPr lang="zh-CN" altLang="en-US" sz="600" dirty="0">
+                <a:latin typeface="Times New Roman" panose="02020603050405020304" pitchFamily="18" charset="0"/>
+                <a:cs typeface="Times New Roman" panose="02020603050405020304" pitchFamily="18" charset="0"/>
+              </a:rPr>
+              <a:t> </a:t>
+            </a:r>
+            <a:r>
+              <a:rPr lang="en-US" sz="600" dirty="0">
+                <a:latin typeface="Times New Roman" panose="02020603050405020304" pitchFamily="18" charset="0"/>
+                <a:cs typeface="Times New Roman" panose="02020603050405020304" pitchFamily="18" charset="0"/>
+              </a:rPr>
+              <a:t>Chroma Features</a:t>
+            </a:r>
+            <a:r>
+              <a:rPr lang="zh-CN" altLang="en-US" sz="600" dirty="0">
+                <a:latin typeface="Times New Roman" panose="02020603050405020304" pitchFamily="18" charset="0"/>
+                <a:cs typeface="Times New Roman" panose="02020603050405020304" pitchFamily="18" charset="0"/>
+              </a:rPr>
+              <a:t> </a:t>
+            </a:r>
+            <a:r>
+              <a:rPr lang="en-US" sz="600" dirty="0">
+                <a:latin typeface="Times New Roman" panose="02020603050405020304" pitchFamily="18" charset="0"/>
+                <a:cs typeface="Times New Roman" panose="02020603050405020304" pitchFamily="18" charset="0"/>
+              </a:rPr>
+              <a:t>Represents</a:t>
+            </a:r>
+            <a:r>
+              <a:rPr lang="zh-CN" altLang="en-US" sz="600" dirty="0">
+                <a:latin typeface="Times New Roman" panose="02020603050405020304" pitchFamily="18" charset="0"/>
+                <a:cs typeface="Times New Roman" panose="02020603050405020304" pitchFamily="18" charset="0"/>
+              </a:rPr>
+              <a:t> </a:t>
+            </a:r>
+            <a:r>
+              <a:rPr lang="en-US" sz="600" dirty="0">
+                <a:latin typeface="Times New Roman" panose="02020603050405020304" pitchFamily="18" charset="0"/>
+                <a:cs typeface="Times New Roman" panose="02020603050405020304" pitchFamily="18" charset="0"/>
+              </a:rPr>
+              <a:t>The Chord</a:t>
+            </a:r>
+            <a:r>
+              <a:rPr lang="zh-CN" altLang="en-US" sz="600" dirty="0">
+                <a:latin typeface="Times New Roman" panose="02020603050405020304" pitchFamily="18" charset="0"/>
+                <a:cs typeface="Times New Roman" panose="02020603050405020304" pitchFamily="18" charset="0"/>
+              </a:rPr>
+              <a:t> </a:t>
+            </a:r>
+            <a:r>
+              <a:rPr lang="en-US" sz="600" dirty="0">
+                <a:latin typeface="Times New Roman" panose="02020603050405020304" pitchFamily="18" charset="0"/>
+                <a:cs typeface="Times New Roman" panose="02020603050405020304" pitchFamily="18" charset="0"/>
+              </a:rPr>
+              <a:t>Notes</a:t>
+            </a:r>
+            <a:r>
+              <a:rPr lang="zh-CN" altLang="en-US" sz="600" dirty="0">
+                <a:latin typeface="Times New Roman" panose="02020603050405020304" pitchFamily="18" charset="0"/>
+                <a:cs typeface="Times New Roman" panose="02020603050405020304" pitchFamily="18" charset="0"/>
+              </a:rPr>
+              <a:t> </a:t>
+            </a:r>
+            <a:r>
+              <a:rPr lang="en-US" sz="600" dirty="0">
+                <a:latin typeface="Times New Roman" panose="02020603050405020304" pitchFamily="18" charset="0"/>
+                <a:cs typeface="Times New Roman" panose="02020603050405020304" pitchFamily="18" charset="0"/>
+              </a:rPr>
+              <a:t>Very Well.</a:t>
+            </a:r>
+          </a:p>
+        </p:txBody>
+      </p:sp>
+      <p:sp>
+        <p:nvSpPr>
+          <p:cNvPr id="7" name="TextBox 6">
+            <a:extLst>
+              <a:ext uri="{FF2B5EF4-FFF2-40B4-BE49-F238E27FC236}">
+                <a16:creationId xmlns:a16="http://schemas.microsoft.com/office/drawing/2014/main" id="{0FE1FEFC-45B2-3059-66BD-C65EE11DEEA5}"/>
+              </a:ext>
+            </a:extLst>
+          </p:cNvPr>
+          <p:cNvSpPr txBox="1"/>
+          <p:nvPr/>
+        </p:nvSpPr>
+        <p:spPr>
+          <a:xfrm>
+            <a:off x="914758" y="4201496"/>
+            <a:ext cx="752948" cy="200055"/>
+          </a:xfrm>
+          <a:prstGeom prst="rect">
+            <a:avLst/>
+          </a:prstGeom>
+          <a:noFill/>
+        </p:spPr>
+        <p:txBody>
+          <a:bodyPr wrap="square" rtlCol="0">
+            <a:spAutoFit/>
+          </a:bodyPr>
+          <a:lstStyle/>
+          <a:p>
+            <a:r>
+              <a:rPr lang="en-US" sz="700" b="1" dirty="0">
+                <a:latin typeface="Times New Roman" panose="02020603050405020304" pitchFamily="18" charset="0"/>
+                <a:cs typeface="Times New Roman" panose="02020603050405020304" pitchFamily="18" charset="0"/>
+              </a:rPr>
+              <a:t>Lead Sheet</a:t>
+            </a:r>
+          </a:p>
+        </p:txBody>
+      </p:sp>
+      <p:sp>
+        <p:nvSpPr>
+          <p:cNvPr id="8" name="TextBox 7">
+            <a:extLst>
+              <a:ext uri="{FF2B5EF4-FFF2-40B4-BE49-F238E27FC236}">
+                <a16:creationId xmlns:a16="http://schemas.microsoft.com/office/drawing/2014/main" id="{43934EC0-883B-DF35-38EE-C5CDA458CAC9}"/>
+              </a:ext>
+            </a:extLst>
+          </p:cNvPr>
+          <p:cNvSpPr txBox="1"/>
+          <p:nvPr/>
+        </p:nvSpPr>
+        <p:spPr>
+          <a:xfrm>
+            <a:off x="957575" y="4723324"/>
+            <a:ext cx="854529" cy="200055"/>
+          </a:xfrm>
+          <a:prstGeom prst="rect">
+            <a:avLst/>
+          </a:prstGeom>
+          <a:noFill/>
+        </p:spPr>
+        <p:txBody>
+          <a:bodyPr wrap="square" rtlCol="0">
+            <a:spAutoFit/>
+          </a:bodyPr>
+          <a:lstStyle/>
+          <a:p>
+            <a:pPr algn="ctr"/>
+            <a:r>
+              <a:rPr lang="en-US" sz="700" b="1" dirty="0">
+                <a:latin typeface="Times New Roman" panose="02020603050405020304" pitchFamily="18" charset="0"/>
+                <a:cs typeface="Times New Roman" panose="02020603050405020304" pitchFamily="18" charset="0"/>
+              </a:rPr>
+              <a:t>Chormagram</a:t>
+            </a:r>
+          </a:p>
+        </p:txBody>
+      </p:sp>
+      <p:pic>
+        <p:nvPicPr>
+          <p:cNvPr id="10" name="Picture 9">
+            <a:extLst>
+              <a:ext uri="{FF2B5EF4-FFF2-40B4-BE49-F238E27FC236}">
+                <a16:creationId xmlns:a16="http://schemas.microsoft.com/office/drawing/2014/main" id="{D87CEA78-294F-9A32-CCB5-D4DCBB94912A}"/>
+              </a:ext>
+            </a:extLst>
+          </p:cNvPr>
+          <p:cNvPicPr>
+            <a:picLocks noChangeAspect="1"/>
+          </p:cNvPicPr>
+          <p:nvPr/>
+        </p:nvPicPr>
+        <p:blipFill>
+          <a:blip r:embed="rId5"/>
+          <a:srcRect t="24100" b="9940"/>
+          <a:stretch/>
+        </p:blipFill>
+        <p:spPr>
+          <a:xfrm>
+            <a:off x="1715180" y="2947500"/>
+            <a:ext cx="1598690" cy="1115222"/>
+          </a:xfrm>
+          <a:prstGeom prst="rect">
+            <a:avLst/>
+          </a:prstGeom>
+        </p:spPr>
+      </p:pic>
+      <p:pic>
+        <p:nvPicPr>
+          <p:cNvPr id="13" name="Picture 12">
+            <a:extLst>
+              <a:ext uri="{FF2B5EF4-FFF2-40B4-BE49-F238E27FC236}">
+                <a16:creationId xmlns:a16="http://schemas.microsoft.com/office/drawing/2014/main" id="{B8DC3AFD-9CD5-A790-E955-C8185DE3C938}"/>
+              </a:ext>
+            </a:extLst>
+          </p:cNvPr>
+          <p:cNvPicPr>
+            <a:picLocks noChangeAspect="1"/>
+          </p:cNvPicPr>
+          <p:nvPr/>
+        </p:nvPicPr>
+        <p:blipFill>
+          <a:blip r:embed="rId6"/>
+          <a:stretch>
+            <a:fillRect/>
+          </a:stretch>
+        </p:blipFill>
+        <p:spPr>
+          <a:xfrm>
+            <a:off x="769088" y="2933321"/>
+            <a:ext cx="883603" cy="1146447"/>
+          </a:xfrm>
+          <a:prstGeom prst="rect">
+            <a:avLst/>
+          </a:prstGeom>
+        </p:spPr>
+      </p:pic>
+      <p:sp>
+        <p:nvSpPr>
+          <p:cNvPr id="14" name="TextBox 13">
+            <a:extLst>
+              <a:ext uri="{FF2B5EF4-FFF2-40B4-BE49-F238E27FC236}">
+                <a16:creationId xmlns:a16="http://schemas.microsoft.com/office/drawing/2014/main" id="{A1DFD112-49EF-8268-0034-D23325636365}"/>
+              </a:ext>
+            </a:extLst>
+          </p:cNvPr>
+          <p:cNvSpPr txBox="1"/>
+          <p:nvPr/>
+        </p:nvSpPr>
+        <p:spPr>
+          <a:xfrm>
+            <a:off x="281365" y="2763783"/>
+            <a:ext cx="3429000" cy="184666"/>
+          </a:xfrm>
+          <a:prstGeom prst="rect">
+            <a:avLst/>
+          </a:prstGeom>
+          <a:noFill/>
+        </p:spPr>
+        <p:txBody>
+          <a:bodyPr wrap="square" rtlCol="0">
+            <a:spAutoFit/>
+          </a:bodyPr>
+          <a:lstStyle/>
+          <a:p>
+            <a:pPr algn="ctr"/>
+            <a:r>
+              <a:rPr lang="en-US" sz="600" i="1" dirty="0">
+                <a:latin typeface="Times New Roman" panose="02020603050405020304" pitchFamily="18" charset="0"/>
+                <a:cs typeface="Times New Roman" panose="02020603050405020304" pitchFamily="18" charset="0"/>
+              </a:rPr>
+              <a:t>Note</a:t>
+            </a:r>
+            <a:r>
+              <a:rPr lang="en-US" sz="600" dirty="0">
+                <a:latin typeface="Times New Roman" panose="02020603050405020304" pitchFamily="18" charset="0"/>
+                <a:cs typeface="Times New Roman" panose="02020603050405020304" pitchFamily="18" charset="0"/>
+              </a:rPr>
+              <a:t>: </a:t>
+            </a:r>
+            <a:r>
+              <a:rPr lang="en-AU" sz="600" dirty="0">
+                <a:latin typeface="Times New Roman" panose="02020603050405020304" pitchFamily="18" charset="0"/>
+                <a:cs typeface="Times New Roman" panose="02020603050405020304" pitchFamily="18" charset="0"/>
+              </a:rPr>
+              <a:t>Overtones of a pitch is in same color. Only previous four overtones are labelled.</a:t>
+            </a:r>
+            <a:endParaRPr lang="en-US" sz="600" dirty="0">
+              <a:latin typeface="Times New Roman" panose="02020603050405020304" pitchFamily="18" charset="0"/>
+              <a:cs typeface="Times New Roman" panose="02020603050405020304" pitchFamily="18" charset="0"/>
+            </a:endParaRPr>
+          </a:p>
+        </p:txBody>
+      </p:sp>
+      <p:pic>
+        <p:nvPicPr>
+          <p:cNvPr id="18" name="Picture 17">
+            <a:extLst>
+              <a:ext uri="{FF2B5EF4-FFF2-40B4-BE49-F238E27FC236}">
+                <a16:creationId xmlns:a16="http://schemas.microsoft.com/office/drawing/2014/main" id="{24E3A2E4-0210-0591-3C57-17BB1873B4DA}"/>
+              </a:ext>
+            </a:extLst>
+          </p:cNvPr>
+          <p:cNvPicPr>
+            <a:picLocks noChangeAspect="1"/>
+          </p:cNvPicPr>
+          <p:nvPr/>
+        </p:nvPicPr>
+        <p:blipFill>
+          <a:blip r:embed="rId7">
+            <a:extLst>
+              <a:ext uri="{BEBA8EAE-BF5A-486C-A8C5-ECC9F3942E4B}">
+                <a14:imgProps xmlns:a14="http://schemas.microsoft.com/office/drawing/2010/main">
+                  <a14:imgLayer r:embed="rId8">
+                    <a14:imgEffect>
+                      <a14:brightnessContrast contrast="20000"/>
+                    </a14:imgEffect>
+                  </a14:imgLayer>
+                </a14:imgProps>
+              </a:ext>
+            </a:extLst>
+          </a:blip>
+          <a:srcRect l="1958" b="14010"/>
+          <a:stretch/>
+        </p:blipFill>
+        <p:spPr>
+          <a:xfrm>
+            <a:off x="1444707" y="4086242"/>
+            <a:ext cx="1874417" cy="438177"/>
+          </a:xfrm>
+          <a:prstGeom prst="rect">
+            <a:avLst/>
+          </a:prstGeom>
+        </p:spPr>
+      </p:pic>
+      <p:sp>
+        <p:nvSpPr>
+          <p:cNvPr id="19" name="TextBox 18">
+            <a:extLst>
+              <a:ext uri="{FF2B5EF4-FFF2-40B4-BE49-F238E27FC236}">
+                <a16:creationId xmlns:a16="http://schemas.microsoft.com/office/drawing/2014/main" id="{57277519-C92E-0AE8-D43A-767951545FC6}"/>
+              </a:ext>
+            </a:extLst>
+          </p:cNvPr>
+          <p:cNvSpPr txBox="1"/>
+          <p:nvPr/>
+        </p:nvSpPr>
+        <p:spPr>
+          <a:xfrm>
+            <a:off x="1715180" y="4434725"/>
+            <a:ext cx="365615" cy="200055"/>
+          </a:xfrm>
+          <a:prstGeom prst="rect">
+            <a:avLst/>
+          </a:prstGeom>
+          <a:noFill/>
+        </p:spPr>
+        <p:txBody>
+          <a:bodyPr wrap="square" rtlCol="0">
+            <a:spAutoFit/>
+          </a:bodyPr>
+          <a:lstStyle/>
+          <a:p>
+            <a:pPr algn="ctr"/>
+            <a:r>
+              <a:rPr lang="en-AU" sz="700" dirty="0">
+                <a:latin typeface="Times New Roman" panose="02020603050405020304" pitchFamily="18" charset="0"/>
+                <a:cs typeface="Times New Roman" panose="02020603050405020304" pitchFamily="18" charset="0"/>
+              </a:rPr>
+              <a:t>Cm</a:t>
+            </a:r>
+            <a:endParaRPr lang="en-US" sz="700" dirty="0">
+              <a:latin typeface="Times New Roman" panose="02020603050405020304" pitchFamily="18" charset="0"/>
+              <a:cs typeface="Times New Roman" panose="02020603050405020304" pitchFamily="18" charset="0"/>
+            </a:endParaRPr>
+          </a:p>
+        </p:txBody>
+      </p:sp>
+      <p:sp>
+        <p:nvSpPr>
+          <p:cNvPr id="20" name="TextBox 19">
+            <a:extLst>
+              <a:ext uri="{FF2B5EF4-FFF2-40B4-BE49-F238E27FC236}">
+                <a16:creationId xmlns:a16="http://schemas.microsoft.com/office/drawing/2014/main" id="{80FF01D4-E7CF-5C8D-3B4E-9081CE72D3F5}"/>
+              </a:ext>
+            </a:extLst>
+          </p:cNvPr>
+          <p:cNvSpPr txBox="1"/>
+          <p:nvPr/>
+        </p:nvSpPr>
+        <p:spPr>
+          <a:xfrm>
+            <a:off x="2660330" y="4452007"/>
+            <a:ext cx="438470" cy="200055"/>
+          </a:xfrm>
+          <a:prstGeom prst="rect">
+            <a:avLst/>
+          </a:prstGeom>
+          <a:noFill/>
+        </p:spPr>
+        <p:txBody>
+          <a:bodyPr wrap="square" rtlCol="0">
+            <a:spAutoFit/>
+          </a:bodyPr>
+          <a:lstStyle/>
+          <a:p>
+            <a:pPr algn="ctr"/>
+            <a:r>
+              <a:rPr lang="en-AU" sz="700" dirty="0">
+                <a:latin typeface="Times New Roman" panose="02020603050405020304" pitchFamily="18" charset="0"/>
+                <a:cs typeface="Times New Roman" panose="02020603050405020304" pitchFamily="18" charset="0"/>
+              </a:rPr>
+              <a:t>Gm7</a:t>
+            </a:r>
+            <a:endParaRPr lang="en-US" sz="700" dirty="0">
+              <a:latin typeface="Times New Roman" panose="02020603050405020304" pitchFamily="18" charset="0"/>
+              <a:cs typeface="Times New Roman" panose="02020603050405020304" pitchFamily="18" charset="0"/>
+            </a:endParaRPr>
+          </a:p>
+        </p:txBody>
+      </p:sp>
+    </p:spTree>
+    <p:extLst>
+      <p:ext uri="{BB962C8B-B14F-4D97-AF65-F5344CB8AC3E}">
+        <p14:creationId xmlns:p14="http://schemas.microsoft.com/office/powerpoint/2010/main" val="3609038688"/>
+      </p:ext>
+    </p:extLst>
+  </p:cSld>
+  <p:clrMapOvr>
+    <a:masterClrMapping/>
+  </p:clrMapOvr>
+</p:sld>
+</file>
+
+<file path=ppt/slides/slide3.xml><?xml version="1.0" encoding="utf-8"?>
+<p:sld xmlns:a="http://schemas.openxmlformats.org/drawingml/2006/main" xmlns:r="http://schemas.openxmlformats.org/officeDocument/2006/relationships" xmlns:p="http://schemas.openxmlformats.org/presentationml/2006/main">
+  <p:cSld>
+    <p:spTree>
+      <p:nvGrpSpPr>
+        <p:cNvPr id="1" name="">
+          <a:extLst>
+            <a:ext uri="{FF2B5EF4-FFF2-40B4-BE49-F238E27FC236}">
+              <a16:creationId xmlns:a16="http://schemas.microsoft.com/office/drawing/2014/main" id="{6BA5C3A3-8C76-7DCE-B3C4-EC5DBCD19CF9}"/>
+            </a:ext>
+          </a:extLst>
+        </p:cNvPr>
+        <p:cNvGrpSpPr/>
+        <p:nvPr/>
+      </p:nvGrpSpPr>
+      <p:grpSpPr>
+        <a:xfrm>
+          <a:off x="0" y="0"/>
+          <a:ext cx="0" cy="0"/>
+          <a:chOff x="0" y="0"/>
+          <a:chExt cx="0" cy="0"/>
+        </a:xfrm>
+      </p:grpSpPr>
+      <p:pic>
+        <p:nvPicPr>
+          <p:cNvPr id="7" name="Picture 6">
+            <a:extLst>
+              <a:ext uri="{FF2B5EF4-FFF2-40B4-BE49-F238E27FC236}">
+                <a16:creationId xmlns:a16="http://schemas.microsoft.com/office/drawing/2014/main" id="{FC8CA049-35EC-6245-13B9-0D5C0550DA55}"/>
+              </a:ext>
+            </a:extLst>
+          </p:cNvPr>
+          <p:cNvPicPr>
+            <a:picLocks noChangeAspect="1"/>
+          </p:cNvPicPr>
+          <p:nvPr/>
+        </p:nvPicPr>
+        <p:blipFill>
+          <a:blip r:embed="rId3"/>
+          <a:stretch>
+            <a:fillRect/>
+          </a:stretch>
+        </p:blipFill>
+        <p:spPr>
+          <a:xfrm>
+            <a:off x="0" y="494066"/>
+            <a:ext cx="6858000" cy="8917867"/>
+          </a:xfrm>
+          <a:prstGeom prst="rect">
+            <a:avLst/>
+          </a:prstGeom>
+        </p:spPr>
+      </p:pic>
+      <p:pic>
+        <p:nvPicPr>
+          <p:cNvPr id="5" name="Picture 4">
+            <a:extLst>
+              <a:ext uri="{FF2B5EF4-FFF2-40B4-BE49-F238E27FC236}">
+                <a16:creationId xmlns:a16="http://schemas.microsoft.com/office/drawing/2014/main" id="{E7E14D54-B227-2ED3-8A59-DC2CDD9DB0BB}"/>
+              </a:ext>
+            </a:extLst>
+          </p:cNvPr>
+          <p:cNvPicPr>
+            <a:picLocks noChangeAspect="1"/>
+          </p:cNvPicPr>
+          <p:nvPr/>
+        </p:nvPicPr>
+        <p:blipFill>
+          <a:blip r:embed="rId4"/>
+          <a:srcRect l="2261" r="26265"/>
+          <a:stretch/>
+        </p:blipFill>
+        <p:spPr>
+          <a:xfrm>
+            <a:off x="3517553" y="5596752"/>
+            <a:ext cx="2734963" cy="1794799"/>
+          </a:xfrm>
+          <a:prstGeom prst="rect">
+            <a:avLst/>
+          </a:prstGeom>
+        </p:spPr>
+      </p:pic>
+      <p:pic>
+        <p:nvPicPr>
+          <p:cNvPr id="8" name="Picture 7">
+            <a:extLst>
+              <a:ext uri="{FF2B5EF4-FFF2-40B4-BE49-F238E27FC236}">
+                <a16:creationId xmlns:a16="http://schemas.microsoft.com/office/drawing/2014/main" id="{466D25E1-B15A-BB6E-1F15-351BD0A3A0FC}"/>
+              </a:ext>
+            </a:extLst>
+          </p:cNvPr>
+          <p:cNvPicPr>
+            <a:picLocks noChangeAspect="1"/>
+          </p:cNvPicPr>
+          <p:nvPr/>
+        </p:nvPicPr>
+        <p:blipFill>
+          <a:blip r:embed="rId5"/>
+          <a:srcRect l="1776" t="10444" r="26409"/>
+          <a:stretch/>
+        </p:blipFill>
+        <p:spPr>
+          <a:xfrm>
+            <a:off x="3490053" y="7218552"/>
+            <a:ext cx="2770702" cy="1620647"/>
+          </a:xfrm>
+          <a:prstGeom prst="rect">
+            <a:avLst/>
+          </a:prstGeom>
+        </p:spPr>
+      </p:pic>
+      <p:pic>
+        <p:nvPicPr>
+          <p:cNvPr id="4" name="Picture 3">
+            <a:extLst>
+              <a:ext uri="{FF2B5EF4-FFF2-40B4-BE49-F238E27FC236}">
+                <a16:creationId xmlns:a16="http://schemas.microsoft.com/office/drawing/2014/main" id="{207E5991-4334-4C99-CB9B-70A0E50373B7}"/>
+              </a:ext>
+            </a:extLst>
+          </p:cNvPr>
+          <p:cNvPicPr>
+            <a:picLocks noChangeAspect="1"/>
+          </p:cNvPicPr>
+          <p:nvPr/>
+        </p:nvPicPr>
+        <p:blipFill>
+          <a:blip r:embed="rId6"/>
+          <a:stretch>
+            <a:fillRect/>
+          </a:stretch>
+        </p:blipFill>
+        <p:spPr>
+          <a:xfrm>
+            <a:off x="1701632" y="4389024"/>
+            <a:ext cx="5156368" cy="1683524"/>
+          </a:xfrm>
+          <a:prstGeom prst="rect">
+            <a:avLst/>
+          </a:prstGeom>
+        </p:spPr>
+      </p:pic>
+    </p:spTree>
+    <p:extLst>
+      <p:ext uri="{BB962C8B-B14F-4D97-AF65-F5344CB8AC3E}">
+        <p14:creationId xmlns:p14="http://schemas.microsoft.com/office/powerpoint/2010/main" val="3044882405"/>
+      </p:ext>
+    </p:extLst>
+  </p:cSld>
+  <p:clrMapOvr>
+    <a:masterClrMapping/>
+  </p:clrMapOvr>
+</p:sld>
+</file>
+
+<file path=ppt/slides/slide4.xml><?xml version="1.0" encoding="utf-8"?>
 <p:sld xmlns:a="http://schemas.openxmlformats.org/drawingml/2006/main" xmlns:r="http://schemas.openxmlformats.org/officeDocument/2006/relationships" xmlns:p="http://schemas.openxmlformats.org/presentationml/2006/main">
   <p:cSld>
     <p:spTree>
@@ -3638,7 +4674,7 @@
 </p:sld>
 </file>
 
-<file path=ppt/slides/slide3.xml><?xml version="1.0" encoding="utf-8"?>
+<file path=ppt/slides/slide5.xml><?xml version="1.0" encoding="utf-8"?>
 <p:sld xmlns:a="http://schemas.openxmlformats.org/drawingml/2006/main" xmlns:r="http://schemas.openxmlformats.org/officeDocument/2006/relationships" xmlns:p="http://schemas.openxmlformats.org/presentationml/2006/main">
   <p:cSld>
     <p:spTree>
@@ -4410,6 +5446,528 @@
     <p:extLst>
       <p:ext uri="{BB962C8B-B14F-4D97-AF65-F5344CB8AC3E}">
         <p14:creationId xmlns:p14="http://schemas.microsoft.com/office/powerpoint/2010/main" val="1624358558"/>
+      </p:ext>
+    </p:extLst>
+  </p:cSld>
+  <p:clrMapOvr>
+    <a:masterClrMapping/>
+  </p:clrMapOvr>
+</p:sld>
+</file>
+
+<file path=ppt/slides/slide6.xml><?xml version="1.0" encoding="utf-8"?>
+<p:sld xmlns:a="http://schemas.openxmlformats.org/drawingml/2006/main" xmlns:r="http://schemas.openxmlformats.org/officeDocument/2006/relationships" xmlns:p="http://schemas.openxmlformats.org/presentationml/2006/main">
+  <p:cSld>
+    <p:spTree>
+      <p:nvGrpSpPr>
+        <p:cNvPr id="1" name="">
+          <a:extLst>
+            <a:ext uri="{FF2B5EF4-FFF2-40B4-BE49-F238E27FC236}">
+              <a16:creationId xmlns:a16="http://schemas.microsoft.com/office/drawing/2014/main" id="{D83EEA6D-AB17-B775-2D6B-955E590E93CD}"/>
+            </a:ext>
+          </a:extLst>
+        </p:cNvPr>
+        <p:cNvGrpSpPr/>
+        <p:nvPr/>
+      </p:nvGrpSpPr>
+      <p:grpSpPr>
+        <a:xfrm>
+          <a:off x="0" y="0"/>
+          <a:ext cx="0" cy="0"/>
+          <a:chOff x="0" y="0"/>
+          <a:chExt cx="0" cy="0"/>
+        </a:xfrm>
+      </p:grpSpPr>
+      <p:pic>
+        <p:nvPicPr>
+          <p:cNvPr id="5" name="Picture 4">
+            <a:extLst>
+              <a:ext uri="{FF2B5EF4-FFF2-40B4-BE49-F238E27FC236}">
+                <a16:creationId xmlns:a16="http://schemas.microsoft.com/office/drawing/2014/main" id="{9AB6AE60-BB37-C97D-35C9-7C4CAEDABDAF}"/>
+              </a:ext>
+            </a:extLst>
+          </p:cNvPr>
+          <p:cNvPicPr>
+            <a:picLocks noChangeAspect="1"/>
+          </p:cNvPicPr>
+          <p:nvPr/>
+        </p:nvPicPr>
+        <p:blipFill>
+          <a:blip r:embed="rId2"/>
+          <a:srcRect b="57039"/>
+          <a:stretch/>
+        </p:blipFill>
+        <p:spPr>
+          <a:xfrm>
+            <a:off x="3520440" y="546101"/>
+            <a:ext cx="2664000" cy="1665541"/>
+          </a:xfrm>
+          <a:prstGeom prst="rect">
+            <a:avLst/>
+          </a:prstGeom>
+        </p:spPr>
+      </p:pic>
+      <p:pic>
+        <p:nvPicPr>
+          <p:cNvPr id="6" name="Picture 5">
+            <a:extLst>
+              <a:ext uri="{FF2B5EF4-FFF2-40B4-BE49-F238E27FC236}">
+                <a16:creationId xmlns:a16="http://schemas.microsoft.com/office/drawing/2014/main" id="{E59E82F1-9EEC-2FA1-8DE6-3CFD9A5BA33C}"/>
+              </a:ext>
+            </a:extLst>
+          </p:cNvPr>
+          <p:cNvPicPr>
+            <a:picLocks noChangeAspect="1"/>
+          </p:cNvPicPr>
+          <p:nvPr/>
+        </p:nvPicPr>
+        <p:blipFill>
+          <a:blip r:embed="rId2"/>
+          <a:srcRect t="52682"/>
+          <a:stretch/>
+        </p:blipFill>
+        <p:spPr>
+          <a:xfrm>
+            <a:off x="856440" y="561341"/>
+            <a:ext cx="2664000" cy="1834481"/>
+          </a:xfrm>
+          <a:prstGeom prst="rect">
+            <a:avLst/>
+          </a:prstGeom>
+        </p:spPr>
+      </p:pic>
+      <p:sp>
+        <p:nvSpPr>
+          <p:cNvPr id="7" name="TextBox 6">
+            <a:extLst>
+              <a:ext uri="{FF2B5EF4-FFF2-40B4-BE49-F238E27FC236}">
+                <a16:creationId xmlns:a16="http://schemas.microsoft.com/office/drawing/2014/main" id="{49AEEBC6-96E9-C58C-DAC9-4513DB036A61}"/>
+              </a:ext>
+            </a:extLst>
+          </p:cNvPr>
+          <p:cNvSpPr txBox="1"/>
+          <p:nvPr/>
+        </p:nvSpPr>
+        <p:spPr>
+          <a:xfrm>
+            <a:off x="1666591" y="253564"/>
+            <a:ext cx="1577098" cy="307777"/>
+          </a:xfrm>
+          <a:prstGeom prst="rect">
+            <a:avLst/>
+          </a:prstGeom>
+          <a:noFill/>
+        </p:spPr>
+        <p:txBody>
+          <a:bodyPr wrap="none" rtlCol="0">
+            <a:spAutoFit/>
+          </a:bodyPr>
+          <a:lstStyle/>
+          <a:p>
+            <a:r>
+              <a:rPr lang="en-US" sz="1400" dirty="0"/>
+              <a:t>(a) GTZAN Beat F1</a:t>
+            </a:r>
+          </a:p>
+        </p:txBody>
+      </p:sp>
+      <p:sp>
+        <p:nvSpPr>
+          <p:cNvPr id="8" name="TextBox 7">
+            <a:extLst>
+              <a:ext uri="{FF2B5EF4-FFF2-40B4-BE49-F238E27FC236}">
+                <a16:creationId xmlns:a16="http://schemas.microsoft.com/office/drawing/2014/main" id="{17E611D8-CD82-F42D-196F-2E03340016DB}"/>
+              </a:ext>
+            </a:extLst>
+          </p:cNvPr>
+          <p:cNvSpPr txBox="1"/>
+          <p:nvPr/>
+        </p:nvSpPr>
+        <p:spPr>
+          <a:xfrm>
+            <a:off x="4155333" y="253564"/>
+            <a:ext cx="1908792" cy="307777"/>
+          </a:xfrm>
+          <a:prstGeom prst="rect">
+            <a:avLst/>
+          </a:prstGeom>
+          <a:noFill/>
+        </p:spPr>
+        <p:txBody>
+          <a:bodyPr wrap="none" rtlCol="0">
+            <a:spAutoFit/>
+          </a:bodyPr>
+          <a:lstStyle/>
+          <a:p>
+            <a:r>
+              <a:rPr lang="en-US" sz="1400" dirty="0"/>
+              <a:t>(b) SMC 0-fold Beat F1</a:t>
+            </a:r>
+          </a:p>
+        </p:txBody>
+      </p:sp>
+      <p:sp>
+        <p:nvSpPr>
+          <p:cNvPr id="9" name="TextBox 8">
+            <a:extLst>
+              <a:ext uri="{FF2B5EF4-FFF2-40B4-BE49-F238E27FC236}">
+                <a16:creationId xmlns:a16="http://schemas.microsoft.com/office/drawing/2014/main" id="{79D8FB27-49BC-A212-5239-3AD8AAEBFF52}"/>
+              </a:ext>
+            </a:extLst>
+          </p:cNvPr>
+          <p:cNvSpPr txBox="1"/>
+          <p:nvPr/>
+        </p:nvSpPr>
+        <p:spPr>
+          <a:xfrm rot="16200000">
+            <a:off x="-69422" y="1117526"/>
+            <a:ext cx="1572546" cy="307777"/>
+          </a:xfrm>
+          <a:prstGeom prst="rect">
+            <a:avLst/>
+          </a:prstGeom>
+          <a:noFill/>
+        </p:spPr>
+        <p:txBody>
+          <a:bodyPr wrap="none" rtlCol="0">
+            <a:spAutoFit/>
+          </a:bodyPr>
+          <a:lstStyle/>
+          <a:p>
+            <a:r>
+              <a:rPr lang="en-US" sz="1400" dirty="0"/>
+              <a:t>BeatThis w. CASM</a:t>
+            </a:r>
+          </a:p>
+        </p:txBody>
+      </p:sp>
+      <p:pic>
+        <p:nvPicPr>
+          <p:cNvPr id="11" name="Picture 10">
+            <a:extLst>
+              <a:ext uri="{FF2B5EF4-FFF2-40B4-BE49-F238E27FC236}">
+                <a16:creationId xmlns:a16="http://schemas.microsoft.com/office/drawing/2014/main" id="{96E2270A-E36A-A017-B8CA-07E4CE06815B}"/>
+              </a:ext>
+            </a:extLst>
+          </p:cNvPr>
+          <p:cNvPicPr>
+            <a:picLocks noChangeAspect="1"/>
+          </p:cNvPicPr>
+          <p:nvPr/>
+        </p:nvPicPr>
+        <p:blipFill>
+          <a:blip r:embed="rId3"/>
+          <a:srcRect t="52588"/>
+          <a:stretch/>
+        </p:blipFill>
+        <p:spPr>
+          <a:xfrm>
+            <a:off x="928440" y="2226882"/>
+            <a:ext cx="2592000" cy="1832516"/>
+          </a:xfrm>
+          <a:prstGeom prst="rect">
+            <a:avLst/>
+          </a:prstGeom>
+        </p:spPr>
+      </p:pic>
+      <p:pic>
+        <p:nvPicPr>
+          <p:cNvPr id="12" name="Picture 11">
+            <a:extLst>
+              <a:ext uri="{FF2B5EF4-FFF2-40B4-BE49-F238E27FC236}">
+                <a16:creationId xmlns:a16="http://schemas.microsoft.com/office/drawing/2014/main" id="{70CA389C-4267-82FC-1D6D-3019901B878B}"/>
+              </a:ext>
+            </a:extLst>
+          </p:cNvPr>
+          <p:cNvPicPr>
+            <a:picLocks noChangeAspect="1"/>
+          </p:cNvPicPr>
+          <p:nvPr/>
+        </p:nvPicPr>
+        <p:blipFill>
+          <a:blip r:embed="rId3"/>
+          <a:srcRect l="4674" b="57137"/>
+          <a:stretch/>
+        </p:blipFill>
+        <p:spPr>
+          <a:xfrm>
+            <a:off x="3696643" y="2211642"/>
+            <a:ext cx="2484000" cy="1665489"/>
+          </a:xfrm>
+          <a:prstGeom prst="rect">
+            <a:avLst/>
+          </a:prstGeom>
+        </p:spPr>
+      </p:pic>
+      <p:pic>
+        <p:nvPicPr>
+          <p:cNvPr id="13" name="Picture 12">
+            <a:extLst>
+              <a:ext uri="{FF2B5EF4-FFF2-40B4-BE49-F238E27FC236}">
+                <a16:creationId xmlns:a16="http://schemas.microsoft.com/office/drawing/2014/main" id="{F1C92B15-D8A6-9C7A-C779-B64BA2B6A882}"/>
+              </a:ext>
+            </a:extLst>
+          </p:cNvPr>
+          <p:cNvPicPr>
+            <a:picLocks noChangeAspect="1"/>
+          </p:cNvPicPr>
+          <p:nvPr/>
+        </p:nvPicPr>
+        <p:blipFill>
+          <a:blip r:embed="rId3"/>
+          <a:srcRect t="96057"/>
+          <a:stretch/>
+        </p:blipFill>
+        <p:spPr>
+          <a:xfrm>
+            <a:off x="3581400" y="3884138"/>
+            <a:ext cx="2592000" cy="152400"/>
+          </a:xfrm>
+          <a:prstGeom prst="rect">
+            <a:avLst/>
+          </a:prstGeom>
+        </p:spPr>
+      </p:pic>
+      <p:sp>
+        <p:nvSpPr>
+          <p:cNvPr id="14" name="TextBox 13">
+            <a:extLst>
+              <a:ext uri="{FF2B5EF4-FFF2-40B4-BE49-F238E27FC236}">
+                <a16:creationId xmlns:a16="http://schemas.microsoft.com/office/drawing/2014/main" id="{4B018276-46A2-593C-1C68-D135295C21D4}"/>
+              </a:ext>
+            </a:extLst>
+          </p:cNvPr>
+          <p:cNvSpPr txBox="1"/>
+          <p:nvPr/>
+        </p:nvSpPr>
+        <p:spPr>
+          <a:xfrm rot="16200000">
+            <a:off x="8577" y="2824537"/>
+            <a:ext cx="1459951" cy="307777"/>
+          </a:xfrm>
+          <a:prstGeom prst="rect">
+            <a:avLst/>
+          </a:prstGeom>
+          <a:noFill/>
+        </p:spPr>
+        <p:txBody>
+          <a:bodyPr wrap="none" rtlCol="0">
+            <a:spAutoFit/>
+          </a:bodyPr>
+          <a:lstStyle/>
+          <a:p>
+            <a:r>
+              <a:rPr lang="en-US" sz="1400" dirty="0"/>
+              <a:t>BeatThis w. DBN</a:t>
+            </a:r>
+          </a:p>
+        </p:txBody>
+      </p:sp>
+      <p:sp>
+        <p:nvSpPr>
+          <p:cNvPr id="17" name="Rectangle 16">
+            <a:extLst>
+              <a:ext uri="{FF2B5EF4-FFF2-40B4-BE49-F238E27FC236}">
+                <a16:creationId xmlns:a16="http://schemas.microsoft.com/office/drawing/2014/main" id="{87988FD7-DF9C-61FF-BC86-13F3CFB9930F}"/>
+              </a:ext>
+            </a:extLst>
+          </p:cNvPr>
+          <p:cNvSpPr/>
+          <p:nvPr/>
+        </p:nvSpPr>
+        <p:spPr>
+          <a:xfrm>
+            <a:off x="5657385" y="1849938"/>
+            <a:ext cx="475786" cy="186609"/>
+          </a:xfrm>
+          <a:prstGeom prst="rect">
+            <a:avLst/>
+          </a:prstGeom>
+          <a:solidFill>
+            <a:schemeClr val="bg1"/>
+          </a:solidFill>
+          <a:ln>
+            <a:noFill/>
+          </a:ln>
+        </p:spPr>
+        <p:style>
+          <a:lnRef idx="2">
+            <a:schemeClr val="accent1">
+              <a:shade val="15000"/>
+            </a:schemeClr>
+          </a:lnRef>
+          <a:fillRef idx="1">
+            <a:schemeClr val="accent1"/>
+          </a:fillRef>
+          <a:effectRef idx="0">
+            <a:schemeClr val="accent1"/>
+          </a:effectRef>
+          <a:fontRef idx="minor">
+            <a:schemeClr val="lt1"/>
+          </a:fontRef>
+        </p:style>
+        <p:txBody>
+          <a:bodyPr rtlCol="0" anchor="ctr"/>
+          <a:lstStyle/>
+          <a:p>
+            <a:pPr algn="ctr"/>
+            <a:endParaRPr lang="en-US"/>
+          </a:p>
+        </p:txBody>
+      </p:sp>
+      <p:sp>
+        <p:nvSpPr>
+          <p:cNvPr id="15" name="TextBox 14">
+            <a:extLst>
+              <a:ext uri="{FF2B5EF4-FFF2-40B4-BE49-F238E27FC236}">
+                <a16:creationId xmlns:a16="http://schemas.microsoft.com/office/drawing/2014/main" id="{C70F9D16-0ED9-A6EE-3278-C521379A91A2}"/>
+              </a:ext>
+            </a:extLst>
+          </p:cNvPr>
+          <p:cNvSpPr txBox="1"/>
+          <p:nvPr/>
+        </p:nvSpPr>
+        <p:spPr>
+          <a:xfrm>
+            <a:off x="5428214" y="1649624"/>
+            <a:ext cx="774731" cy="415498"/>
+          </a:xfrm>
+          <a:prstGeom prst="rect">
+            <a:avLst/>
+          </a:prstGeom>
+          <a:noFill/>
+          <a:ln w="12700">
+            <a:noFill/>
+          </a:ln>
+        </p:spPr>
+        <p:style>
+          <a:lnRef idx="2">
+            <a:schemeClr val="dk1"/>
+          </a:lnRef>
+          <a:fillRef idx="1">
+            <a:schemeClr val="lt1"/>
+          </a:fillRef>
+          <a:effectRef idx="0">
+            <a:schemeClr val="dk1"/>
+          </a:effectRef>
+          <a:fontRef idx="minor">
+            <a:schemeClr val="dk1"/>
+          </a:fontRef>
+        </p:style>
+        <p:txBody>
+          <a:bodyPr wrap="square" rtlCol="0">
+            <a:spAutoFit/>
+          </a:bodyPr>
+          <a:lstStyle/>
+          <a:p>
+            <a:pPr algn="r"/>
+            <a:r>
+              <a:rPr lang="en-US" altLang="zh-CN" sz="1050" b="1" dirty="0">
+                <a:solidFill>
+                  <a:srgbClr val="7A8189"/>
+                </a:solidFill>
+                <a:latin typeface="Aptos SemiBold" panose="020B0004020202020204" pitchFamily="34" charset="0"/>
+              </a:rPr>
+              <a:t>BeatThis</a:t>
+            </a:r>
+            <a:r>
+              <a:rPr lang="zh-CN" altLang="en-US" sz="1050" b="1" dirty="0">
+                <a:solidFill>
+                  <a:srgbClr val="7A8189"/>
+                </a:solidFill>
+                <a:latin typeface="Aptos SemiBold" panose="020B0004020202020204" pitchFamily="34" charset="0"/>
+              </a:rPr>
+              <a:t> </a:t>
+            </a:r>
+            <a:r>
+              <a:rPr lang="en-AU" altLang="zh-CN" sz="1050" b="1" dirty="0">
+                <a:solidFill>
+                  <a:srgbClr val="7A8189"/>
+                </a:solidFill>
+                <a:latin typeface="Aptos SemiBold" panose="020B0004020202020204" pitchFamily="34" charset="0"/>
+              </a:rPr>
+              <a:t>(</a:t>
+            </a:r>
+            <a:r>
+              <a:rPr lang="en-US" altLang="zh-CN" sz="1050" b="1" dirty="0">
+                <a:solidFill>
+                  <a:srgbClr val="7A8189"/>
+                </a:solidFill>
+                <a:latin typeface="Aptos SemiBold" panose="020B0004020202020204" pitchFamily="34" charset="0"/>
+              </a:rPr>
+              <a:t>direct)</a:t>
+            </a:r>
+            <a:endParaRPr lang="en-US" sz="1050" b="1" dirty="0">
+              <a:solidFill>
+                <a:srgbClr val="7A8189"/>
+              </a:solidFill>
+              <a:latin typeface="Aptos SemiBold" panose="020B0004020202020204" pitchFamily="34" charset="0"/>
+            </a:endParaRPr>
+          </a:p>
+        </p:txBody>
+      </p:sp>
+      <p:pic>
+        <p:nvPicPr>
+          <p:cNvPr id="2" name="Picture 1">
+            <a:extLst>
+              <a:ext uri="{FF2B5EF4-FFF2-40B4-BE49-F238E27FC236}">
+                <a16:creationId xmlns:a16="http://schemas.microsoft.com/office/drawing/2014/main" id="{9C4AD5D8-B340-B24D-5CE1-F74EBFD9EBC8}"/>
+              </a:ext>
+            </a:extLst>
+          </p:cNvPr>
+          <p:cNvPicPr>
+            <a:picLocks noChangeAspect="1"/>
+          </p:cNvPicPr>
+          <p:nvPr/>
+        </p:nvPicPr>
+        <p:blipFill>
+          <a:blip r:embed="rId4"/>
+          <a:srcRect l="8525" t="10504" b="17703"/>
+          <a:stretch/>
+        </p:blipFill>
+        <p:spPr>
+          <a:xfrm>
+            <a:off x="997288" y="4187157"/>
+            <a:ext cx="5135883" cy="2185934"/>
+          </a:xfrm>
+          <a:prstGeom prst="rect">
+            <a:avLst/>
+          </a:prstGeom>
+        </p:spPr>
+      </p:pic>
+      <p:pic>
+        <p:nvPicPr>
+          <p:cNvPr id="3" name="Picture 2">
+            <a:extLst>
+              <a:ext uri="{FF2B5EF4-FFF2-40B4-BE49-F238E27FC236}">
+                <a16:creationId xmlns:a16="http://schemas.microsoft.com/office/drawing/2014/main" id="{EB237283-5BEF-07AF-0259-24088D237A66}"/>
+              </a:ext>
+            </a:extLst>
+          </p:cNvPr>
+          <p:cNvPicPr>
+            <a:picLocks noChangeAspect="1"/>
+          </p:cNvPicPr>
+          <p:nvPr/>
+        </p:nvPicPr>
+        <p:blipFill>
+          <a:blip r:embed="rId4"/>
+          <a:srcRect l="8525" t="86095"/>
+          <a:stretch/>
+        </p:blipFill>
+        <p:spPr>
+          <a:xfrm>
+            <a:off x="997288" y="6447056"/>
+            <a:ext cx="5311354" cy="437838"/>
+          </a:xfrm>
+          <a:prstGeom prst="rect">
+            <a:avLst/>
+          </a:prstGeom>
+        </p:spPr>
+      </p:pic>
+    </p:spTree>
+    <p:extLst>
+      <p:ext uri="{BB962C8B-B14F-4D97-AF65-F5344CB8AC3E}">
+        <p14:creationId xmlns:p14="http://schemas.microsoft.com/office/powerpoint/2010/main" val="2824763514"/>
       </p:ext>
     </p:extLst>
   </p:cSld>

</xml_diff>